<commit_message>
Add killer use-case slide, reference-architecture framing, one-time payment clarification
</commit_message>
<xml_diff>
--- a/VaultMemo/VaultMemo_Pitch_Deck.pptx
+++ b/VaultMemo/VaultMemo_Pitch_Deck.pptx
@@ -13,9 +13,10 @@
     <p:sldId id="261" r:id="rId7"/>
     <p:sldId id="262" r:id="rId8"/>
     <p:sldId id="263" r:id="rId9"/>
+    <p:sldId id="264" r:id="rId10"/>
   </p:sldIdLst>
   <p:notesMasterIdLst>
-    <p:notesMasterId r:id="rId10"/>
+    <p:notesMasterId r:id="rId11"/>
   </p:notesMasterIdLst>
   <p:sldSz cx="12192000" cy="6858000"/>
   <p:notesSz cx="6858000" cy="12192000"/>
@@ -1149,6 +1150,94 @@
             <a:fld id="{F7021451-1387-4CA6-816F-3879F97B5CBC}" type="slidenum">
               <a:rPr lang="en-US"/>
               <a:t>8</a:t>
+            </a:fld>
+            <a:endParaRPr lang="en-US"/>
+          </a:p>
+        </p:txBody>
+      </p:sp>
+    </p:spTree>
+    <p:extLst>
+      <p:ext uri="{BB962C8B-B14F-4D97-AF65-F5344CB8AC3E}">
+        <p14:creationId xmlns:p14="http://schemas.microsoft.com/office/powerpoint/2010/main" val="1024086991"/>
+      </p:ext>
+    </p:extLst>
+  </p:cSld>
+  <p:clrMapOvr>
+    <a:masterClrMapping/>
+  </p:clrMapOvr>
+</p:notes>
+</file>
+
+<file path=ppt/notesSlides/notesSlide9.xml><?xml version="1.0" encoding="utf-8"?>
+<p:notes xmlns:a="http://schemas.openxmlformats.org/drawingml/2006/main" xmlns:r="http://schemas.openxmlformats.org/officeDocument/2006/relationships" xmlns:p="http://schemas.openxmlformats.org/presentationml/2006/main">
+  <p:cSld>
+    <p:spTree>
+      <p:nvGrpSpPr>
+        <p:cNvPr id="1" name=""/>
+        <p:cNvGrpSpPr/>
+        <p:nvPr/>
+      </p:nvGrpSpPr>
+      <p:grpSpPr>
+        <a:xfrm>
+          <a:off x="0" y="0"/>
+          <a:ext cx="0" cy="0"/>
+          <a:chOff x="0" y="0"/>
+          <a:chExt cx="0" cy="0"/>
+        </a:xfrm>
+      </p:grpSpPr>
+      <p:sp>
+        <p:nvSpPr>
+          <p:cNvPr id="2" name="Slide Image Placeholder 1"/>
+          <p:cNvSpPr>
+            <a:spLocks noGrp="1" noRot="1" noChangeAspect="1"/>
+          </p:cNvSpPr>
+          <p:nvPr>
+            <p:ph type="sldImg"/>
+          </p:nvPr>
+        </p:nvSpPr>
+        <p:spPr/>
+      </p:sp>
+      <p:sp>
+        <p:nvSpPr>
+          <p:cNvPr id="3" name="Notes Placeholder 2"/>
+          <p:cNvSpPr>
+            <a:spLocks noGrp="1"/>
+          </p:cNvSpPr>
+          <p:nvPr>
+            <p:ph type="body" idx="1"/>
+          </p:nvPr>
+        </p:nvSpPr>
+        <p:spPr/>
+        <p:txBody>
+          <a:bodyPr/>
+          <a:lstStyle/>
+          <a:p>
+            <a:r>
+              <a:rPr lang="en-US" dirty="0"/>
+              <a:t/>
+            </a:r>
+            <a:endParaRPr lang="en-US" dirty="0"/>
+          </a:p>
+        </p:txBody>
+      </p:sp>
+      <p:sp>
+        <p:nvSpPr>
+          <p:cNvPr id="4" name="Slide Number Placeholder 3"/>
+          <p:cNvSpPr>
+            <a:spLocks noGrp="1"/>
+          </p:cNvSpPr>
+          <p:nvPr>
+            <p:ph type="sldNum" sz="quarter" idx="10"/>
+          </p:nvPr>
+        </p:nvSpPr>
+        <p:spPr/>
+        <p:txBody>
+          <a:bodyPr/>
+          <a:lstStyle/>
+          <a:p>
+            <a:fld id="{F7021451-1387-4CA6-816F-3879F97B5CBC}" type="slidenum">
+              <a:rPr lang="en-US"/>
+              <a:t>9</a:t>
             </a:fld>
             <a:endParaRPr lang="en-US"/>
           </a:p>
@@ -2162,7 +2251,7 @@
                 <a:ea typeface="Calibri" pitchFamily="34" charset="-122"/>
                 <a:cs typeface="Calibri" pitchFamily="34" charset="-120"/>
               </a:rPr>
-              <a:t>THE SOLUTION</a:t>
+              <a:t>WHO NEEDS THIS</a:t>
             </a:r>
             <a:endParaRPr lang="en-US" sz="1200" dirty="0"/>
           </a:p>
@@ -2201,7 +2290,7 @@
                 <a:ea typeface="Cambria" pitchFamily="34" charset="-122"/>
                 <a:cs typeface="Cambria" pitchFamily="34" charset="-120"/>
               </a:rPr>
-              <a:t>Encrypted on-device. Proven on-chain.</a:t>
+              <a:t>Tamper-proof timestamps aren't a nice-to-have for everyone.</a:t>
             </a:r>
             <a:endParaRPr lang="en-US" sz="3400" dirty="0"/>
           </a:p>
@@ -2231,112 +2320,53 @@
       </p:sp>
       <p:sp>
         <p:nvSpPr>
-          <p:cNvPr id="5" name="Shape 3"/>
-          <p:cNvSpPr/>
-          <p:nvPr/>
-        </p:nvSpPr>
-        <p:spPr>
-          <a:xfrm>
-            <a:off x="822960" y="2423160"/>
-            <a:ext cx="502920" cy="502920"/>
-          </a:xfrm>
-          <a:prstGeom prst="ellipse">
-            <a:avLst/>
-          </a:prstGeom>
-          <a:solidFill>
-            <a:srgbClr val="1FA971"/>
-          </a:solidFill>
-          <a:ln/>
-        </p:spPr>
-      </p:sp>
-      <p:sp>
-        <p:nvSpPr>
-          <p:cNvPr id="6" name="Text 4"/>
-          <p:cNvSpPr/>
-          <p:nvPr/>
-        </p:nvSpPr>
-        <p:spPr>
-          <a:xfrm>
-            <a:off x="822960" y="2423160"/>
-            <a:ext cx="502920" cy="502920"/>
-          </a:xfrm>
-          <a:prstGeom prst="rect">
-            <a:avLst/>
-          </a:prstGeom>
-          <a:noFill/>
-          <a:ln/>
-        </p:spPr>
-        <p:txBody>
-          <a:bodyPr wrap="square" lIns="0" tIns="0" rIns="0" bIns="0" rtlCol="0" anchor="ctr"/>
-          <a:lstStyle/>
-          <a:p>
-            <a:pPr algn="ctr" indent="0" marL="0">
-              <a:buNone/>
-            </a:pPr>
-            <a:r>
-              <a:rPr lang="en-US" sz="2000" b="1" dirty="0">
-                <a:solidFill>
-                  <a:srgbClr val="0B1410"/>
+          <p:cNvPr id="5" name="Text 3"/>
+          <p:cNvSpPr/>
+          <p:nvPr/>
+        </p:nvSpPr>
+        <p:spPr>
+          <a:xfrm>
+            <a:off x="822960" y="2468880"/>
+            <a:ext cx="2880360" cy="640080"/>
+          </a:xfrm>
+          <a:prstGeom prst="rect">
+            <a:avLst/>
+          </a:prstGeom>
+          <a:noFill/>
+          <a:ln/>
+        </p:spPr>
+        <p:txBody>
+          <a:bodyPr wrap="square" lIns="0" tIns="0" rIns="0" bIns="0" rtlCol="0" anchor="ctr"/>
+          <a:lstStyle/>
+          <a:p>
+            <a:pPr indent="0" marL="0">
+              <a:buNone/>
+            </a:pPr>
+            <a:r>
+              <a:rPr lang="en-US" sz="1800" b="1" dirty="0">
+                <a:solidFill>
+                  <a:srgbClr val="7EE8B8"/>
                 </a:solidFill>
                 <a:latin typeface="Cambria" pitchFamily="34" charset="0"/>
                 <a:ea typeface="Cambria" pitchFamily="34" charset="-122"/>
                 <a:cs typeface="Cambria" pitchFamily="34" charset="-120"/>
               </a:rPr>
-              <a:t>1</a:t>
-            </a:r>
-            <a:endParaRPr lang="en-US" sz="2000" dirty="0"/>
-          </a:p>
-        </p:txBody>
-      </p:sp>
-      <p:sp>
-        <p:nvSpPr>
-          <p:cNvPr id="7" name="Text 5"/>
-          <p:cNvSpPr/>
-          <p:nvPr/>
-        </p:nvSpPr>
-        <p:spPr>
-          <a:xfrm>
-            <a:off x="822960" y="3108960"/>
-            <a:ext cx="2880360" cy="457200"/>
-          </a:xfrm>
-          <a:prstGeom prst="rect">
-            <a:avLst/>
-          </a:prstGeom>
-          <a:noFill/>
-          <a:ln/>
-        </p:spPr>
-        <p:txBody>
-          <a:bodyPr wrap="square" lIns="0" tIns="0" rIns="0" bIns="0" rtlCol="0" anchor="ctr"/>
-          <a:lstStyle/>
-          <a:p>
-            <a:pPr indent="0" marL="0">
-              <a:buNone/>
-            </a:pPr>
-            <a:r>
-              <a:rPr lang="en-US" sz="1650" b="1" dirty="0">
-                <a:solidFill>
-                  <a:srgbClr val="F5F7F5"/>
-                </a:solidFill>
-                <a:latin typeface="Cambria" pitchFamily="34" charset="0"/>
-                <a:ea typeface="Cambria" pitchFamily="34" charset="-122"/>
-                <a:cs typeface="Cambria" pitchFamily="34" charset="-120"/>
-              </a:rPr>
-              <a:t>Seed Vault signs</a:t>
-            </a:r>
-            <a:endParaRPr lang="en-US" sz="1650" dirty="0"/>
-          </a:p>
-        </p:txBody>
-      </p:sp>
-      <p:sp>
-        <p:nvSpPr>
-          <p:cNvPr id="8" name="Text 6"/>
-          <p:cNvSpPr/>
-          <p:nvPr/>
-        </p:nvSpPr>
-        <p:spPr>
-          <a:xfrm>
-            <a:off x="822960" y="3611880"/>
-            <a:ext cx="2880360" cy="1554480"/>
+              <a:t>Journalists</a:t>
+            </a:r>
+            <a:endParaRPr lang="en-US" sz="1800" dirty="0"/>
+          </a:p>
+        </p:txBody>
+      </p:sp>
+      <p:sp>
+        <p:nvSpPr>
+          <p:cNvPr id="6" name="Text 4"/>
+          <p:cNvSpPr/>
+          <p:nvPr/>
+        </p:nvSpPr>
+        <p:spPr>
+          <a:xfrm>
+            <a:off x="822960" y="3154680"/>
+            <a:ext cx="2880360" cy="2011680"/>
           </a:xfrm>
           <a:prstGeom prst="rect">
             <a:avLst/>
@@ -2350,20 +2380,20 @@
           <a:p>
             <a:pPr indent="0" marL="0">
               <a:lnSpc>
-                <a:spcPct val="125000"/>
+                <a:spcPct val="130000"/>
               </a:lnSpc>
               <a:buNone/>
             </a:pPr>
             <a:r>
               <a:rPr lang="en-US" sz="1300" dirty="0">
                 <a:solidFill>
-                  <a:srgbClr val="9FB3A8"/>
+                  <a:srgbClr val="DCE6E0"/>
                 </a:solidFill>
                 <a:latin typeface="Calibri" pitchFamily="34" charset="0"/>
                 <a:ea typeface="Calibri" pitchFamily="34" charset="-122"/>
                 <a:cs typeface="Calibri" pitchFamily="34" charset="-120"/>
               </a:rPr>
-              <a:t>A fixed message is signed by the user's Solana wallet via Seed Vault — deterministic, never leaves the device.</a:t>
+              <a:t>Proving a source record or investigation note existed — and wasn't altered — at a specific date, without exposing it.</a:t>
             </a:r>
             <a:endParaRPr lang="en-US" sz="1300" dirty="0"/>
           </a:p>
@@ -2371,7 +2401,7 @@
       </p:sp>
       <p:sp>
         <p:nvSpPr>
-          <p:cNvPr id="9" name="Shape 7"/>
+          <p:cNvPr id="7" name="Shape 5"/>
           <p:cNvSpPr/>
           <p:nvPr/>
         </p:nvSpPr>
@@ -2393,112 +2423,53 @@
       </p:sp>
       <p:sp>
         <p:nvSpPr>
-          <p:cNvPr id="10" name="Shape 8"/>
-          <p:cNvSpPr/>
-          <p:nvPr/>
-        </p:nvSpPr>
-        <p:spPr>
-          <a:xfrm>
-            <a:off x="4572000" y="2423160"/>
-            <a:ext cx="502920" cy="502920"/>
-          </a:xfrm>
-          <a:prstGeom prst="ellipse">
-            <a:avLst/>
-          </a:prstGeom>
-          <a:solidFill>
-            <a:srgbClr val="1FA971"/>
-          </a:solidFill>
-          <a:ln/>
-        </p:spPr>
-      </p:sp>
-      <p:sp>
-        <p:nvSpPr>
-          <p:cNvPr id="11" name="Text 9"/>
-          <p:cNvSpPr/>
-          <p:nvPr/>
-        </p:nvSpPr>
-        <p:spPr>
-          <a:xfrm>
-            <a:off x="4572000" y="2423160"/>
-            <a:ext cx="502920" cy="502920"/>
-          </a:xfrm>
-          <a:prstGeom prst="rect">
-            <a:avLst/>
-          </a:prstGeom>
-          <a:noFill/>
-          <a:ln/>
-        </p:spPr>
-        <p:txBody>
-          <a:bodyPr wrap="square" lIns="0" tIns="0" rIns="0" bIns="0" rtlCol="0" anchor="ctr"/>
-          <a:lstStyle/>
-          <a:p>
-            <a:pPr algn="ctr" indent="0" marL="0">
-              <a:buNone/>
-            </a:pPr>
-            <a:r>
-              <a:rPr lang="en-US" sz="2000" b="1" dirty="0">
-                <a:solidFill>
-                  <a:srgbClr val="0B1410"/>
+          <p:cNvPr id="8" name="Text 6"/>
+          <p:cNvSpPr/>
+          <p:nvPr/>
+        </p:nvSpPr>
+        <p:spPr>
+          <a:xfrm>
+            <a:off x="4572000" y="2468880"/>
+            <a:ext cx="2880360" cy="640080"/>
+          </a:xfrm>
+          <a:prstGeom prst="rect">
+            <a:avLst/>
+          </a:prstGeom>
+          <a:noFill/>
+          <a:ln/>
+        </p:spPr>
+        <p:txBody>
+          <a:bodyPr wrap="square" lIns="0" tIns="0" rIns="0" bIns="0" rtlCol="0" anchor="ctr"/>
+          <a:lstStyle/>
+          <a:p>
+            <a:pPr indent="0" marL="0">
+              <a:buNone/>
+            </a:pPr>
+            <a:r>
+              <a:rPr lang="en-US" sz="1800" b="1" dirty="0">
+                <a:solidFill>
+                  <a:srgbClr val="7EE8B8"/>
                 </a:solidFill>
                 <a:latin typeface="Cambria" pitchFamily="34" charset="0"/>
                 <a:ea typeface="Cambria" pitchFamily="34" charset="-122"/>
                 <a:cs typeface="Cambria" pitchFamily="34" charset="-120"/>
               </a:rPr>
-              <a:t>2</a:t>
-            </a:r>
-            <a:endParaRPr lang="en-US" sz="2000" dirty="0"/>
-          </a:p>
-        </p:txBody>
-      </p:sp>
-      <p:sp>
-        <p:nvSpPr>
-          <p:cNvPr id="12" name="Text 10"/>
-          <p:cNvSpPr/>
-          <p:nvPr/>
-        </p:nvSpPr>
-        <p:spPr>
-          <a:xfrm>
-            <a:off x="4572000" y="3108960"/>
-            <a:ext cx="2880360" cy="457200"/>
-          </a:xfrm>
-          <a:prstGeom prst="rect">
-            <a:avLst/>
-          </a:prstGeom>
-          <a:noFill/>
-          <a:ln/>
-        </p:spPr>
-        <p:txBody>
-          <a:bodyPr wrap="square" lIns="0" tIns="0" rIns="0" bIns="0" rtlCol="0" anchor="ctr"/>
-          <a:lstStyle/>
-          <a:p>
-            <a:pPr indent="0" marL="0">
-              <a:buNone/>
-            </a:pPr>
-            <a:r>
-              <a:rPr lang="en-US" sz="1650" b="1" dirty="0">
-                <a:solidFill>
-                  <a:srgbClr val="F5F7F5"/>
-                </a:solidFill>
-                <a:latin typeface="Cambria" pitchFamily="34" charset="0"/>
-                <a:ea typeface="Cambria" pitchFamily="34" charset="-122"/>
-                <a:cs typeface="Cambria" pitchFamily="34" charset="-120"/>
-              </a:rPr>
-              <a:t>Key is derived</a:t>
-            </a:r>
-            <a:endParaRPr lang="en-US" sz="1650" dirty="0"/>
-          </a:p>
-        </p:txBody>
-      </p:sp>
-      <p:sp>
-        <p:nvSpPr>
-          <p:cNvPr id="13" name="Text 11"/>
-          <p:cNvSpPr/>
-          <p:nvPr/>
-        </p:nvSpPr>
-        <p:spPr>
-          <a:xfrm>
-            <a:off x="4572000" y="3611880"/>
-            <a:ext cx="2880360" cy="1554480"/>
+              <a:t>Lawyers</a:t>
+            </a:r>
+            <a:endParaRPr lang="en-US" sz="1800" dirty="0"/>
+          </a:p>
+        </p:txBody>
+      </p:sp>
+      <p:sp>
+        <p:nvSpPr>
+          <p:cNvPr id="9" name="Text 7"/>
+          <p:cNvSpPr/>
+          <p:nvPr/>
+        </p:nvSpPr>
+        <p:spPr>
+          <a:xfrm>
+            <a:off x="4572000" y="3154680"/>
+            <a:ext cx="2880360" cy="2011680"/>
           </a:xfrm>
           <a:prstGeom prst="rect">
             <a:avLst/>
@@ -2512,20 +2483,20 @@
           <a:p>
             <a:pPr indent="0" marL="0">
               <a:lnSpc>
-                <a:spcPct val="125000"/>
+                <a:spcPct val="130000"/>
               </a:lnSpc>
               <a:buNone/>
             </a:pPr>
             <a:r>
               <a:rPr lang="en-US" sz="1300" dirty="0">
                 <a:solidFill>
-                  <a:srgbClr val="9FB3A8"/>
+                  <a:srgbClr val="DCE6E0"/>
                 </a:solidFill>
                 <a:latin typeface="Calibri" pitchFamily="34" charset="0"/>
                 <a:ea typeface="Calibri" pitchFamily="34" charset="-122"/>
                 <a:cs typeface="Calibri" pitchFamily="34" charset="-120"/>
               </a:rPr>
-              <a:t>SHA-256 of the signature derives an AES-256 key, held only in memory. No servers, no accounts, no cloud.</a:t>
+              <a:t>Timestamped case notes and evidence logs that can be independently verified, not just self-attested.</a:t>
             </a:r>
             <a:endParaRPr lang="en-US" sz="1300" dirty="0"/>
           </a:p>
@@ -2533,7 +2504,7 @@
       </p:sp>
       <p:sp>
         <p:nvSpPr>
-          <p:cNvPr id="14" name="Shape 12"/>
+          <p:cNvPr id="10" name="Shape 8"/>
           <p:cNvSpPr/>
           <p:nvPr/>
         </p:nvSpPr>
@@ -2555,178 +2526,119 @@
       </p:sp>
       <p:sp>
         <p:nvSpPr>
-          <p:cNvPr id="15" name="Shape 13"/>
-          <p:cNvSpPr/>
-          <p:nvPr/>
-        </p:nvSpPr>
-        <p:spPr>
-          <a:xfrm>
-            <a:off x="8321040" y="2423160"/>
-            <a:ext cx="502920" cy="502920"/>
-          </a:xfrm>
-          <a:prstGeom prst="ellipse">
-            <a:avLst/>
-          </a:prstGeom>
-          <a:solidFill>
-            <a:srgbClr val="1FA971"/>
-          </a:solidFill>
-          <a:ln/>
-        </p:spPr>
-      </p:sp>
-      <p:sp>
-        <p:nvSpPr>
-          <p:cNvPr id="16" name="Text 14"/>
-          <p:cNvSpPr/>
-          <p:nvPr/>
-        </p:nvSpPr>
-        <p:spPr>
-          <a:xfrm>
-            <a:off x="8321040" y="2423160"/>
-            <a:ext cx="502920" cy="502920"/>
-          </a:xfrm>
-          <a:prstGeom prst="rect">
-            <a:avLst/>
-          </a:prstGeom>
-          <a:noFill/>
-          <a:ln/>
-        </p:spPr>
-        <p:txBody>
-          <a:bodyPr wrap="square" lIns="0" tIns="0" rIns="0" bIns="0" rtlCol="0" anchor="ctr"/>
-          <a:lstStyle/>
-          <a:p>
-            <a:pPr algn="ctr" indent="0" marL="0">
-              <a:buNone/>
-            </a:pPr>
-            <a:r>
-              <a:rPr lang="en-US" sz="2000" b="1" dirty="0">
-                <a:solidFill>
-                  <a:srgbClr val="0B1410"/>
+          <p:cNvPr id="11" name="Text 9"/>
+          <p:cNvSpPr/>
+          <p:nvPr/>
+        </p:nvSpPr>
+        <p:spPr>
+          <a:xfrm>
+            <a:off x="8321040" y="2468880"/>
+            <a:ext cx="2880360" cy="640080"/>
+          </a:xfrm>
+          <a:prstGeom prst="rect">
+            <a:avLst/>
+          </a:prstGeom>
+          <a:noFill/>
+          <a:ln/>
+        </p:spPr>
+        <p:txBody>
+          <a:bodyPr wrap="square" lIns="0" tIns="0" rIns="0" bIns="0" rtlCol="0" anchor="ctr"/>
+          <a:lstStyle/>
+          <a:p>
+            <a:pPr indent="0" marL="0">
+              <a:buNone/>
+            </a:pPr>
+            <a:r>
+              <a:rPr lang="en-US" sz="1800" b="1" dirty="0">
+                <a:solidFill>
+                  <a:srgbClr val="7EE8B8"/>
                 </a:solidFill>
                 <a:latin typeface="Cambria" pitchFamily="34" charset="0"/>
                 <a:ea typeface="Cambria" pitchFamily="34" charset="-122"/>
                 <a:cs typeface="Cambria" pitchFamily="34" charset="-120"/>
               </a:rPr>
-              <a:t>3</a:t>
-            </a:r>
-            <a:endParaRPr lang="en-US" sz="2000" dirty="0"/>
-          </a:p>
-        </p:txBody>
-      </p:sp>
-      <p:sp>
-        <p:nvSpPr>
-          <p:cNvPr id="17" name="Text 15"/>
-          <p:cNvSpPr/>
-          <p:nvPr/>
-        </p:nvSpPr>
-        <p:spPr>
-          <a:xfrm>
-            <a:off x="8321040" y="3108960"/>
-            <a:ext cx="2880360" cy="457200"/>
-          </a:xfrm>
-          <a:prstGeom prst="rect">
-            <a:avLst/>
-          </a:prstGeom>
-          <a:noFill/>
-          <a:ln/>
-        </p:spPr>
-        <p:txBody>
-          <a:bodyPr wrap="square" lIns="0" tIns="0" rIns="0" bIns="0" rtlCol="0" anchor="ctr"/>
+              <a:t>IP creators &amp; researchers</a:t>
+            </a:r>
+            <a:endParaRPr lang="en-US" sz="1800" dirty="0"/>
+          </a:p>
+        </p:txBody>
+      </p:sp>
+      <p:sp>
+        <p:nvSpPr>
+          <p:cNvPr id="12" name="Text 10"/>
+          <p:cNvSpPr/>
+          <p:nvPr/>
+        </p:nvSpPr>
+        <p:spPr>
+          <a:xfrm>
+            <a:off x="8321040" y="3154680"/>
+            <a:ext cx="2880360" cy="2011680"/>
+          </a:xfrm>
+          <a:prstGeom prst="rect">
+            <a:avLst/>
+          </a:prstGeom>
+          <a:noFill/>
+          <a:ln/>
+        </p:spPr>
+        <p:txBody>
+          <a:bodyPr wrap="square" lIns="0" tIns="0" rIns="0" bIns="0" rtlCol="0" anchor="t"/>
           <a:lstStyle/>
           <a:p>
             <a:pPr indent="0" marL="0">
-              <a:buNone/>
-            </a:pPr>
-            <a:r>
-              <a:rPr lang="en-US" sz="1650" b="1" dirty="0">
-                <a:solidFill>
-                  <a:srgbClr val="F5F7F5"/>
+              <a:lnSpc>
+                <a:spcPct val="130000"/>
+              </a:lnSpc>
+              <a:buNone/>
+            </a:pPr>
+            <a:r>
+              <a:rPr lang="en-US" sz="1300" dirty="0">
+                <a:solidFill>
+                  <a:srgbClr val="DCE6E0"/>
+                </a:solidFill>
+                <a:latin typeface="Calibri" pitchFamily="34" charset="0"/>
+                <a:ea typeface="Calibri" pitchFamily="34" charset="-122"/>
+                <a:cs typeface="Calibri" pitchFamily="34" charset="-120"/>
+              </a:rPr>
+              <a:t>Proof of when an idea, draft, or finding was first conceived — before any public disclosure.</a:t>
+            </a:r>
+            <a:endParaRPr lang="en-US" sz="1300" dirty="0"/>
+          </a:p>
+        </p:txBody>
+      </p:sp>
+      <p:sp>
+        <p:nvSpPr>
+          <p:cNvPr id="13" name="Text 11"/>
+          <p:cNvSpPr/>
+          <p:nvPr/>
+        </p:nvSpPr>
+        <p:spPr>
+          <a:xfrm>
+            <a:off x="548640" y="5715000"/>
+            <a:ext cx="11064240" cy="548640"/>
+          </a:xfrm>
+          <a:prstGeom prst="rect">
+            <a:avLst/>
+          </a:prstGeom>
+          <a:noFill/>
+          <a:ln/>
+        </p:spPr>
+        <p:txBody>
+          <a:bodyPr wrap="square" lIns="0" tIns="0" rIns="0" bIns="0" rtlCol="0" anchor="ctr"/>
+          <a:lstStyle/>
+          <a:p>
+            <a:pPr algn="ctr" indent="0" marL="0">
+              <a:buNone/>
+            </a:pPr>
+            <a:r>
+              <a:rPr lang="en-US" sz="1400" i="1" dirty="0">
+                <a:solidFill>
+                  <a:srgbClr val="7EE8B8"/>
                 </a:solidFill>
                 <a:latin typeface="Cambria" pitchFamily="34" charset="0"/>
                 <a:ea typeface="Cambria" pitchFamily="34" charset="-122"/>
                 <a:cs typeface="Cambria" pitchFamily="34" charset="-120"/>
               </a:rPr>
-              <a:t>Hash goes on-chain</a:t>
-            </a:r>
-            <a:endParaRPr lang="en-US" sz="1650" dirty="0"/>
-          </a:p>
-        </p:txBody>
-      </p:sp>
-      <p:sp>
-        <p:nvSpPr>
-          <p:cNvPr id="18" name="Text 16"/>
-          <p:cNvSpPr/>
-          <p:nvPr/>
-        </p:nvSpPr>
-        <p:spPr>
-          <a:xfrm>
-            <a:off x="8321040" y="3611880"/>
-            <a:ext cx="2880360" cy="1554480"/>
-          </a:xfrm>
-          <a:prstGeom prst="rect">
-            <a:avLst/>
-          </a:prstGeom>
-          <a:noFill/>
-          <a:ln/>
-        </p:spPr>
-        <p:txBody>
-          <a:bodyPr wrap="square" lIns="0" tIns="0" rIns="0" bIns="0" rtlCol="0" anchor="t"/>
-          <a:lstStyle/>
-          <a:p>
-            <a:pPr indent="0" marL="0">
-              <a:lnSpc>
-                <a:spcPct val="125000"/>
-              </a:lnSpc>
-              <a:buNone/>
-            </a:pPr>
-            <a:r>
-              <a:rPr lang="en-US" sz="1300" dirty="0">
-                <a:solidFill>
-                  <a:srgbClr val="9FB3A8"/>
-                </a:solidFill>
-                <a:latin typeface="Calibri" pitchFamily="34" charset="0"/>
-                <a:ea typeface="Calibri" pitchFamily="34" charset="-122"/>
-                <a:cs typeface="Calibri" pitchFamily="34" charset="-120"/>
-              </a:rPr>
-              <a:t>An SPL Memo transaction records the note's hash fingerprint on Solana mainnet — tamper-proof proof of existence.</a:t>
-            </a:r>
-            <a:endParaRPr lang="en-US" sz="1300" dirty="0"/>
-          </a:p>
-        </p:txBody>
-      </p:sp>
-      <p:sp>
-        <p:nvSpPr>
-          <p:cNvPr id="19" name="Text 17"/>
-          <p:cNvSpPr/>
-          <p:nvPr/>
-        </p:nvSpPr>
-        <p:spPr>
-          <a:xfrm>
-            <a:off x="548640" y="5715000"/>
-            <a:ext cx="11064240" cy="548640"/>
-          </a:xfrm>
-          <a:prstGeom prst="rect">
-            <a:avLst/>
-          </a:prstGeom>
-          <a:noFill/>
-          <a:ln/>
-        </p:spPr>
-        <p:txBody>
-          <a:bodyPr wrap="square" lIns="0" tIns="0" rIns="0" bIns="0" rtlCol="0" anchor="ctr"/>
-          <a:lstStyle/>
-          <a:p>
-            <a:pPr algn="ctr" indent="0" marL="0">
-              <a:buNone/>
-            </a:pPr>
-            <a:r>
-              <a:rPr lang="en-US" sz="1400" i="1" dirty="0">
-                <a:solidFill>
-                  <a:srgbClr val="7EE8B8"/>
-                </a:solidFill>
-                <a:latin typeface="Cambria" pitchFamily="34" charset="0"/>
-                <a:ea typeface="Cambria" pitchFamily="34" charset="-122"/>
-                <a:cs typeface="Cambria" pitchFamily="34" charset="-120"/>
-              </a:rPr>
-              <a:t>No other vault app pairs true local-only encryption with an independently verifiable on-chain record.</a:t>
+              <a:t>For these users, a screenshot or a private note isn't proof of anything. An independently verifiable, on-chain timestamp is.</a:t>
             </a:r>
             <a:endParaRPr lang="en-US" sz="1400" dirty="0"/>
           </a:p>
@@ -2743,6 +2655,641 @@
 <file path=ppt/slides/slide4.xml><?xml version="1.0" encoding="utf-8"?>
 <p:sld xmlns:a="http://schemas.openxmlformats.org/drawingml/2006/main" xmlns:r="http://schemas.openxmlformats.org/officeDocument/2006/relationships" xmlns:p="http://schemas.openxmlformats.org/presentationml/2006/main">
   <p:cSld name="Slide 4">
+    <p:bg>
+      <p:bgPr>
+        <a:solidFill>
+          <a:srgbClr val="0B1410"/>
+        </a:solidFill>
+      </p:bgPr>
+    </p:bg>
+    <p:spTree>
+      <p:nvGrpSpPr>
+        <p:cNvPr id="1" name=""/>
+        <p:cNvGrpSpPr/>
+        <p:nvPr/>
+      </p:nvGrpSpPr>
+      <p:grpSpPr>
+        <a:xfrm>
+          <a:off x="0" y="0"/>
+          <a:ext cx="0" cy="0"/>
+          <a:chOff x="0" y="0"/>
+          <a:chExt cx="0" cy="0"/>
+        </a:xfrm>
+      </p:grpSpPr>
+      <p:sp>
+        <p:nvSpPr>
+          <p:cNvPr id="2" name="Text 0"/>
+          <p:cNvSpPr/>
+          <p:nvPr/>
+        </p:nvSpPr>
+        <p:spPr>
+          <a:xfrm>
+            <a:off x="548640" y="256032"/>
+            <a:ext cx="7315200" cy="320040"/>
+          </a:xfrm>
+          <a:prstGeom prst="rect">
+            <a:avLst/>
+          </a:prstGeom>
+          <a:noFill/>
+          <a:ln/>
+        </p:spPr>
+        <p:txBody>
+          <a:bodyPr wrap="square" lIns="0" tIns="0" rIns="0" bIns="0" rtlCol="0" anchor="ctr"/>
+          <a:lstStyle/>
+          <a:p>
+            <a:pPr algn="l" indent="0" marL="0">
+              <a:buNone/>
+            </a:pPr>
+            <a:r>
+              <a:rPr lang="en-US" sz="1200" b="1" spc="200" kern="0" dirty="0">
+                <a:solidFill>
+                  <a:srgbClr val="7EE8B8"/>
+                </a:solidFill>
+                <a:latin typeface="Calibri" pitchFamily="34" charset="0"/>
+                <a:ea typeface="Calibri" pitchFamily="34" charset="-122"/>
+                <a:cs typeface="Calibri" pitchFamily="34" charset="-120"/>
+              </a:rPr>
+              <a:t>THE SOLUTION</a:t>
+            </a:r>
+            <a:endParaRPr lang="en-US" sz="1200" dirty="0"/>
+          </a:p>
+        </p:txBody>
+      </p:sp>
+      <p:sp>
+        <p:nvSpPr>
+          <p:cNvPr id="3" name="Text 1"/>
+          <p:cNvSpPr/>
+          <p:nvPr/>
+        </p:nvSpPr>
+        <p:spPr>
+          <a:xfrm>
+            <a:off x="548640" y="502920"/>
+            <a:ext cx="11064240" cy="822960"/>
+          </a:xfrm>
+          <a:prstGeom prst="rect">
+            <a:avLst/>
+          </a:prstGeom>
+          <a:noFill/>
+          <a:ln/>
+        </p:spPr>
+        <p:txBody>
+          <a:bodyPr wrap="square" lIns="0" tIns="0" rIns="0" bIns="0" rtlCol="0" anchor="ctr"/>
+          <a:lstStyle/>
+          <a:p>
+            <a:pPr algn="l" indent="0" marL="0">
+              <a:buNone/>
+            </a:pPr>
+            <a:r>
+              <a:rPr lang="en-US" sz="3400" b="1" dirty="0">
+                <a:solidFill>
+                  <a:srgbClr val="F5F7F5"/>
+                </a:solidFill>
+                <a:latin typeface="Cambria" pitchFamily="34" charset="0"/>
+                <a:ea typeface="Cambria" pitchFamily="34" charset="-122"/>
+                <a:cs typeface="Cambria" pitchFamily="34" charset="-120"/>
+              </a:rPr>
+              <a:t>Encrypted on-device. Proven on-chain.</a:t>
+            </a:r>
+            <a:endParaRPr lang="en-US" sz="3400" dirty="0"/>
+          </a:p>
+        </p:txBody>
+      </p:sp>
+      <p:sp>
+        <p:nvSpPr>
+          <p:cNvPr id="4" name="Shape 2"/>
+          <p:cNvSpPr/>
+          <p:nvPr/>
+        </p:nvSpPr>
+        <p:spPr>
+          <a:xfrm>
+            <a:off x="548640" y="2148840"/>
+            <a:ext cx="3429000" cy="3291840"/>
+          </a:xfrm>
+          <a:prstGeom prst="roundRect">
+            <a:avLst>
+              <a:gd name="adj" fmla="val 3333"/>
+            </a:avLst>
+          </a:prstGeom>
+          <a:solidFill>
+            <a:srgbClr val="132018"/>
+          </a:solidFill>
+          <a:ln/>
+        </p:spPr>
+      </p:sp>
+      <p:sp>
+        <p:nvSpPr>
+          <p:cNvPr id="5" name="Shape 3"/>
+          <p:cNvSpPr/>
+          <p:nvPr/>
+        </p:nvSpPr>
+        <p:spPr>
+          <a:xfrm>
+            <a:off x="822960" y="2423160"/>
+            <a:ext cx="502920" cy="502920"/>
+          </a:xfrm>
+          <a:prstGeom prst="ellipse">
+            <a:avLst/>
+          </a:prstGeom>
+          <a:solidFill>
+            <a:srgbClr val="1FA971"/>
+          </a:solidFill>
+          <a:ln/>
+        </p:spPr>
+      </p:sp>
+      <p:sp>
+        <p:nvSpPr>
+          <p:cNvPr id="6" name="Text 4"/>
+          <p:cNvSpPr/>
+          <p:nvPr/>
+        </p:nvSpPr>
+        <p:spPr>
+          <a:xfrm>
+            <a:off x="822960" y="2423160"/>
+            <a:ext cx="502920" cy="502920"/>
+          </a:xfrm>
+          <a:prstGeom prst="rect">
+            <a:avLst/>
+          </a:prstGeom>
+          <a:noFill/>
+          <a:ln/>
+        </p:spPr>
+        <p:txBody>
+          <a:bodyPr wrap="square" lIns="0" tIns="0" rIns="0" bIns="0" rtlCol="0" anchor="ctr"/>
+          <a:lstStyle/>
+          <a:p>
+            <a:pPr algn="ctr" indent="0" marL="0">
+              <a:buNone/>
+            </a:pPr>
+            <a:r>
+              <a:rPr lang="en-US" sz="2000" b="1" dirty="0">
+                <a:solidFill>
+                  <a:srgbClr val="0B1410"/>
+                </a:solidFill>
+                <a:latin typeface="Cambria" pitchFamily="34" charset="0"/>
+                <a:ea typeface="Cambria" pitchFamily="34" charset="-122"/>
+                <a:cs typeface="Cambria" pitchFamily="34" charset="-120"/>
+              </a:rPr>
+              <a:t>1</a:t>
+            </a:r>
+            <a:endParaRPr lang="en-US" sz="2000" dirty="0"/>
+          </a:p>
+        </p:txBody>
+      </p:sp>
+      <p:sp>
+        <p:nvSpPr>
+          <p:cNvPr id="7" name="Text 5"/>
+          <p:cNvSpPr/>
+          <p:nvPr/>
+        </p:nvSpPr>
+        <p:spPr>
+          <a:xfrm>
+            <a:off x="822960" y="3108960"/>
+            <a:ext cx="2880360" cy="457200"/>
+          </a:xfrm>
+          <a:prstGeom prst="rect">
+            <a:avLst/>
+          </a:prstGeom>
+          <a:noFill/>
+          <a:ln/>
+        </p:spPr>
+        <p:txBody>
+          <a:bodyPr wrap="square" lIns="0" tIns="0" rIns="0" bIns="0" rtlCol="0" anchor="ctr"/>
+          <a:lstStyle/>
+          <a:p>
+            <a:pPr indent="0" marL="0">
+              <a:buNone/>
+            </a:pPr>
+            <a:r>
+              <a:rPr lang="en-US" sz="1650" b="1" dirty="0">
+                <a:solidFill>
+                  <a:srgbClr val="F5F7F5"/>
+                </a:solidFill>
+                <a:latin typeface="Cambria" pitchFamily="34" charset="0"/>
+                <a:ea typeface="Cambria" pitchFamily="34" charset="-122"/>
+                <a:cs typeface="Cambria" pitchFamily="34" charset="-120"/>
+              </a:rPr>
+              <a:t>Seed Vault signs</a:t>
+            </a:r>
+            <a:endParaRPr lang="en-US" sz="1650" dirty="0"/>
+          </a:p>
+        </p:txBody>
+      </p:sp>
+      <p:sp>
+        <p:nvSpPr>
+          <p:cNvPr id="8" name="Text 6"/>
+          <p:cNvSpPr/>
+          <p:nvPr/>
+        </p:nvSpPr>
+        <p:spPr>
+          <a:xfrm>
+            <a:off x="822960" y="3611880"/>
+            <a:ext cx="2880360" cy="1554480"/>
+          </a:xfrm>
+          <a:prstGeom prst="rect">
+            <a:avLst/>
+          </a:prstGeom>
+          <a:noFill/>
+          <a:ln/>
+        </p:spPr>
+        <p:txBody>
+          <a:bodyPr wrap="square" lIns="0" tIns="0" rIns="0" bIns="0" rtlCol="0" anchor="t"/>
+          <a:lstStyle/>
+          <a:p>
+            <a:pPr indent="0" marL="0">
+              <a:lnSpc>
+                <a:spcPct val="125000"/>
+              </a:lnSpc>
+              <a:buNone/>
+            </a:pPr>
+            <a:r>
+              <a:rPr lang="en-US" sz="1300" dirty="0">
+                <a:solidFill>
+                  <a:srgbClr val="9FB3A8"/>
+                </a:solidFill>
+                <a:latin typeface="Calibri" pitchFamily="34" charset="0"/>
+                <a:ea typeface="Calibri" pitchFamily="34" charset="-122"/>
+                <a:cs typeface="Calibri" pitchFamily="34" charset="-120"/>
+              </a:rPr>
+              <a:t>A fixed message is signed by the user's Solana wallet via Seed Vault — deterministic, never leaves the device.</a:t>
+            </a:r>
+            <a:endParaRPr lang="en-US" sz="1300" dirty="0"/>
+          </a:p>
+        </p:txBody>
+      </p:sp>
+      <p:sp>
+        <p:nvSpPr>
+          <p:cNvPr id="9" name="Shape 7"/>
+          <p:cNvSpPr/>
+          <p:nvPr/>
+        </p:nvSpPr>
+        <p:spPr>
+          <a:xfrm>
+            <a:off x="4297680" y="2148840"/>
+            <a:ext cx="3429000" cy="3291840"/>
+          </a:xfrm>
+          <a:prstGeom prst="roundRect">
+            <a:avLst>
+              <a:gd name="adj" fmla="val 3333"/>
+            </a:avLst>
+          </a:prstGeom>
+          <a:solidFill>
+            <a:srgbClr val="132018"/>
+          </a:solidFill>
+          <a:ln/>
+        </p:spPr>
+      </p:sp>
+      <p:sp>
+        <p:nvSpPr>
+          <p:cNvPr id="10" name="Shape 8"/>
+          <p:cNvSpPr/>
+          <p:nvPr/>
+        </p:nvSpPr>
+        <p:spPr>
+          <a:xfrm>
+            <a:off x="4572000" y="2423160"/>
+            <a:ext cx="502920" cy="502920"/>
+          </a:xfrm>
+          <a:prstGeom prst="ellipse">
+            <a:avLst/>
+          </a:prstGeom>
+          <a:solidFill>
+            <a:srgbClr val="1FA971"/>
+          </a:solidFill>
+          <a:ln/>
+        </p:spPr>
+      </p:sp>
+      <p:sp>
+        <p:nvSpPr>
+          <p:cNvPr id="11" name="Text 9"/>
+          <p:cNvSpPr/>
+          <p:nvPr/>
+        </p:nvSpPr>
+        <p:spPr>
+          <a:xfrm>
+            <a:off x="4572000" y="2423160"/>
+            <a:ext cx="502920" cy="502920"/>
+          </a:xfrm>
+          <a:prstGeom prst="rect">
+            <a:avLst/>
+          </a:prstGeom>
+          <a:noFill/>
+          <a:ln/>
+        </p:spPr>
+        <p:txBody>
+          <a:bodyPr wrap="square" lIns="0" tIns="0" rIns="0" bIns="0" rtlCol="0" anchor="ctr"/>
+          <a:lstStyle/>
+          <a:p>
+            <a:pPr algn="ctr" indent="0" marL="0">
+              <a:buNone/>
+            </a:pPr>
+            <a:r>
+              <a:rPr lang="en-US" sz="2000" b="1" dirty="0">
+                <a:solidFill>
+                  <a:srgbClr val="0B1410"/>
+                </a:solidFill>
+                <a:latin typeface="Cambria" pitchFamily="34" charset="0"/>
+                <a:ea typeface="Cambria" pitchFamily="34" charset="-122"/>
+                <a:cs typeface="Cambria" pitchFamily="34" charset="-120"/>
+              </a:rPr>
+              <a:t>2</a:t>
+            </a:r>
+            <a:endParaRPr lang="en-US" sz="2000" dirty="0"/>
+          </a:p>
+        </p:txBody>
+      </p:sp>
+      <p:sp>
+        <p:nvSpPr>
+          <p:cNvPr id="12" name="Text 10"/>
+          <p:cNvSpPr/>
+          <p:nvPr/>
+        </p:nvSpPr>
+        <p:spPr>
+          <a:xfrm>
+            <a:off x="4572000" y="3108960"/>
+            <a:ext cx="2880360" cy="457200"/>
+          </a:xfrm>
+          <a:prstGeom prst="rect">
+            <a:avLst/>
+          </a:prstGeom>
+          <a:noFill/>
+          <a:ln/>
+        </p:spPr>
+        <p:txBody>
+          <a:bodyPr wrap="square" lIns="0" tIns="0" rIns="0" bIns="0" rtlCol="0" anchor="ctr"/>
+          <a:lstStyle/>
+          <a:p>
+            <a:pPr indent="0" marL="0">
+              <a:buNone/>
+            </a:pPr>
+            <a:r>
+              <a:rPr lang="en-US" sz="1650" b="1" dirty="0">
+                <a:solidFill>
+                  <a:srgbClr val="F5F7F5"/>
+                </a:solidFill>
+                <a:latin typeface="Cambria" pitchFamily="34" charset="0"/>
+                <a:ea typeface="Cambria" pitchFamily="34" charset="-122"/>
+                <a:cs typeface="Cambria" pitchFamily="34" charset="-120"/>
+              </a:rPr>
+              <a:t>Key is derived</a:t>
+            </a:r>
+            <a:endParaRPr lang="en-US" sz="1650" dirty="0"/>
+          </a:p>
+        </p:txBody>
+      </p:sp>
+      <p:sp>
+        <p:nvSpPr>
+          <p:cNvPr id="13" name="Text 11"/>
+          <p:cNvSpPr/>
+          <p:nvPr/>
+        </p:nvSpPr>
+        <p:spPr>
+          <a:xfrm>
+            <a:off x="4572000" y="3611880"/>
+            <a:ext cx="2880360" cy="1554480"/>
+          </a:xfrm>
+          <a:prstGeom prst="rect">
+            <a:avLst/>
+          </a:prstGeom>
+          <a:noFill/>
+          <a:ln/>
+        </p:spPr>
+        <p:txBody>
+          <a:bodyPr wrap="square" lIns="0" tIns="0" rIns="0" bIns="0" rtlCol="0" anchor="t"/>
+          <a:lstStyle/>
+          <a:p>
+            <a:pPr indent="0" marL="0">
+              <a:lnSpc>
+                <a:spcPct val="125000"/>
+              </a:lnSpc>
+              <a:buNone/>
+            </a:pPr>
+            <a:r>
+              <a:rPr lang="en-US" sz="1300" dirty="0">
+                <a:solidFill>
+                  <a:srgbClr val="9FB3A8"/>
+                </a:solidFill>
+                <a:latin typeface="Calibri" pitchFamily="34" charset="0"/>
+                <a:ea typeface="Calibri" pitchFamily="34" charset="-122"/>
+                <a:cs typeface="Calibri" pitchFamily="34" charset="-120"/>
+              </a:rPr>
+              <a:t>SHA-256 of the signature derives an AES-256 key, held only in memory. No servers, no accounts, no cloud.</a:t>
+            </a:r>
+            <a:endParaRPr lang="en-US" sz="1300" dirty="0"/>
+          </a:p>
+        </p:txBody>
+      </p:sp>
+      <p:sp>
+        <p:nvSpPr>
+          <p:cNvPr id="14" name="Shape 12"/>
+          <p:cNvSpPr/>
+          <p:nvPr/>
+        </p:nvSpPr>
+        <p:spPr>
+          <a:xfrm>
+            <a:off x="8046720" y="2148840"/>
+            <a:ext cx="3429000" cy="3291840"/>
+          </a:xfrm>
+          <a:prstGeom prst="roundRect">
+            <a:avLst>
+              <a:gd name="adj" fmla="val 3333"/>
+            </a:avLst>
+          </a:prstGeom>
+          <a:solidFill>
+            <a:srgbClr val="132018"/>
+          </a:solidFill>
+          <a:ln/>
+        </p:spPr>
+      </p:sp>
+      <p:sp>
+        <p:nvSpPr>
+          <p:cNvPr id="15" name="Shape 13"/>
+          <p:cNvSpPr/>
+          <p:nvPr/>
+        </p:nvSpPr>
+        <p:spPr>
+          <a:xfrm>
+            <a:off x="8321040" y="2423160"/>
+            <a:ext cx="502920" cy="502920"/>
+          </a:xfrm>
+          <a:prstGeom prst="ellipse">
+            <a:avLst/>
+          </a:prstGeom>
+          <a:solidFill>
+            <a:srgbClr val="1FA971"/>
+          </a:solidFill>
+          <a:ln/>
+        </p:spPr>
+      </p:sp>
+      <p:sp>
+        <p:nvSpPr>
+          <p:cNvPr id="16" name="Text 14"/>
+          <p:cNvSpPr/>
+          <p:nvPr/>
+        </p:nvSpPr>
+        <p:spPr>
+          <a:xfrm>
+            <a:off x="8321040" y="2423160"/>
+            <a:ext cx="502920" cy="502920"/>
+          </a:xfrm>
+          <a:prstGeom prst="rect">
+            <a:avLst/>
+          </a:prstGeom>
+          <a:noFill/>
+          <a:ln/>
+        </p:spPr>
+        <p:txBody>
+          <a:bodyPr wrap="square" lIns="0" tIns="0" rIns="0" bIns="0" rtlCol="0" anchor="ctr"/>
+          <a:lstStyle/>
+          <a:p>
+            <a:pPr algn="ctr" indent="0" marL="0">
+              <a:buNone/>
+            </a:pPr>
+            <a:r>
+              <a:rPr lang="en-US" sz="2000" b="1" dirty="0">
+                <a:solidFill>
+                  <a:srgbClr val="0B1410"/>
+                </a:solidFill>
+                <a:latin typeface="Cambria" pitchFamily="34" charset="0"/>
+                <a:ea typeface="Cambria" pitchFamily="34" charset="-122"/>
+                <a:cs typeface="Cambria" pitchFamily="34" charset="-120"/>
+              </a:rPr>
+              <a:t>3</a:t>
+            </a:r>
+            <a:endParaRPr lang="en-US" sz="2000" dirty="0"/>
+          </a:p>
+        </p:txBody>
+      </p:sp>
+      <p:sp>
+        <p:nvSpPr>
+          <p:cNvPr id="17" name="Text 15"/>
+          <p:cNvSpPr/>
+          <p:nvPr/>
+        </p:nvSpPr>
+        <p:spPr>
+          <a:xfrm>
+            <a:off x="8321040" y="3108960"/>
+            <a:ext cx="2880360" cy="457200"/>
+          </a:xfrm>
+          <a:prstGeom prst="rect">
+            <a:avLst/>
+          </a:prstGeom>
+          <a:noFill/>
+          <a:ln/>
+        </p:spPr>
+        <p:txBody>
+          <a:bodyPr wrap="square" lIns="0" tIns="0" rIns="0" bIns="0" rtlCol="0" anchor="ctr"/>
+          <a:lstStyle/>
+          <a:p>
+            <a:pPr indent="0" marL="0">
+              <a:buNone/>
+            </a:pPr>
+            <a:r>
+              <a:rPr lang="en-US" sz="1650" b="1" dirty="0">
+                <a:solidFill>
+                  <a:srgbClr val="F5F7F5"/>
+                </a:solidFill>
+                <a:latin typeface="Cambria" pitchFamily="34" charset="0"/>
+                <a:ea typeface="Cambria" pitchFamily="34" charset="-122"/>
+                <a:cs typeface="Cambria" pitchFamily="34" charset="-120"/>
+              </a:rPr>
+              <a:t>Hash goes on-chain</a:t>
+            </a:r>
+            <a:endParaRPr lang="en-US" sz="1650" dirty="0"/>
+          </a:p>
+        </p:txBody>
+      </p:sp>
+      <p:sp>
+        <p:nvSpPr>
+          <p:cNvPr id="18" name="Text 16"/>
+          <p:cNvSpPr/>
+          <p:nvPr/>
+        </p:nvSpPr>
+        <p:spPr>
+          <a:xfrm>
+            <a:off x="8321040" y="3611880"/>
+            <a:ext cx="2880360" cy="1554480"/>
+          </a:xfrm>
+          <a:prstGeom prst="rect">
+            <a:avLst/>
+          </a:prstGeom>
+          <a:noFill/>
+          <a:ln/>
+        </p:spPr>
+        <p:txBody>
+          <a:bodyPr wrap="square" lIns="0" tIns="0" rIns="0" bIns="0" rtlCol="0" anchor="t"/>
+          <a:lstStyle/>
+          <a:p>
+            <a:pPr indent="0" marL="0">
+              <a:lnSpc>
+                <a:spcPct val="125000"/>
+              </a:lnSpc>
+              <a:buNone/>
+            </a:pPr>
+            <a:r>
+              <a:rPr lang="en-US" sz="1300" dirty="0">
+                <a:solidFill>
+                  <a:srgbClr val="9FB3A8"/>
+                </a:solidFill>
+                <a:latin typeface="Calibri" pitchFamily="34" charset="0"/>
+                <a:ea typeface="Calibri" pitchFamily="34" charset="-122"/>
+                <a:cs typeface="Calibri" pitchFamily="34" charset="-120"/>
+              </a:rPr>
+              <a:t>An SPL Memo transaction records the note's hash fingerprint on Solana mainnet — tamper-proof proof of existence.</a:t>
+            </a:r>
+            <a:endParaRPr lang="en-US" sz="1300" dirty="0"/>
+          </a:p>
+        </p:txBody>
+      </p:sp>
+      <p:sp>
+        <p:nvSpPr>
+          <p:cNvPr id="19" name="Text 17"/>
+          <p:cNvSpPr/>
+          <p:nvPr/>
+        </p:nvSpPr>
+        <p:spPr>
+          <a:xfrm>
+            <a:off x="548640" y="5715000"/>
+            <a:ext cx="11064240" cy="548640"/>
+          </a:xfrm>
+          <a:prstGeom prst="rect">
+            <a:avLst/>
+          </a:prstGeom>
+          <a:noFill/>
+          <a:ln/>
+        </p:spPr>
+        <p:txBody>
+          <a:bodyPr wrap="square" lIns="0" tIns="0" rIns="0" bIns="0" rtlCol="0" anchor="ctr"/>
+          <a:lstStyle/>
+          <a:p>
+            <a:pPr algn="ctr" indent="0" marL="0">
+              <a:buNone/>
+            </a:pPr>
+            <a:r>
+              <a:rPr lang="en-US" sz="1400" i="1" dirty="0">
+                <a:solidFill>
+                  <a:srgbClr val="7EE8B8"/>
+                </a:solidFill>
+                <a:latin typeface="Cambria" pitchFamily="34" charset="0"/>
+                <a:ea typeface="Cambria" pitchFamily="34" charset="-122"/>
+                <a:cs typeface="Cambria" pitchFamily="34" charset="-120"/>
+              </a:rPr>
+              <a:t>No other vault app pairs true local-only encryption with an independently verifiable on-chain record.</a:t>
+            </a:r>
+            <a:endParaRPr lang="en-US" sz="1400" dirty="0"/>
+          </a:p>
+        </p:txBody>
+      </p:sp>
+    </p:spTree>
+  </p:cSld>
+  <p:clrMapOvr>
+    <a:masterClrMapping/>
+  </p:clrMapOvr>
+</p:sld>
+</file>
+
+<file path=ppt/slides/slide5.xml><?xml version="1.0" encoding="utf-8"?>
+<p:sld xmlns:a="http://schemas.openxmlformats.org/drawingml/2006/main" xmlns:r="http://schemas.openxmlformats.org/officeDocument/2006/relationships" xmlns:p="http://schemas.openxmlformats.org/presentationml/2006/main">
+  <p:cSld name="Slide 5">
     <p:bg>
       <p:bgPr>
         <a:solidFill>
@@ -3316,7 +3863,7 @@
                 <a:ea typeface="Calibri" pitchFamily="34" charset="-122"/>
                 <a:cs typeface="Calibri" pitchFamily="34" charset="-120"/>
               </a:rPr>
-              <a:t>Tiered on-chain payments unlock storage capacity — native support for the Seeker economy's own token.</a:t>
+              <a:t>One-time, pay-per-save pricing by size tier (no subscription) — tiered on-chain payments unlock storage capacity, with native support for the Seeker economy's own token.</a:t>
             </a:r>
             <a:endParaRPr lang="en-US" sz="1250" dirty="0"/>
           </a:p>
@@ -3475,7 +4022,7 @@
                 <a:ea typeface="Cambria" pitchFamily="34" charset="-122"/>
                 <a:cs typeface="Cambria" pitchFamily="34" charset="-120"/>
               </a:rPr>
-              <a:t>It's a niche use case, but few — if any — apps in the Seeker ecosystem lean on Seed Vault this deeply: the entire security model is derived from signMessages, not bolted onto it.</a:t>
+              <a:t>It's a niche use case, but few — if any — apps in the Seeker ecosystem lean on Seed Vault this deeply: the entire security model is derived from signMessages, not bolted onto it. That makes VaultMemo a reference architecture other Seeker developers can study for deep Seed Vault integration.</a:t>
             </a:r>
             <a:endParaRPr lang="en-US" sz="1350" dirty="0"/>
           </a:p>
@@ -3489,9 +4036,9 @@
 </p:sld>
 </file>
 
-<file path=ppt/slides/slide5.xml><?xml version="1.0" encoding="utf-8"?>
+<file path=ppt/slides/slide6.xml><?xml version="1.0" encoding="utf-8"?>
 <p:sld xmlns:a="http://schemas.openxmlformats.org/drawingml/2006/main" xmlns:r="http://schemas.openxmlformats.org/officeDocument/2006/relationships" xmlns:p="http://schemas.openxmlformats.org/presentationml/2006/main">
-  <p:cSld name="Slide 5">
+  <p:cSld name="Slide 6">
     <p:bg>
       <p:bgPr>
         <a:solidFill>
@@ -4098,9 +4645,9 @@
 </p:sld>
 </file>
 
-<file path=ppt/slides/slide6.xml><?xml version="1.0" encoding="utf-8"?>
+<file path=ppt/slides/slide7.xml><?xml version="1.0" encoding="utf-8"?>
 <p:sld xmlns:a="http://schemas.openxmlformats.org/drawingml/2006/main" xmlns:r="http://schemas.openxmlformats.org/officeDocument/2006/relationships" xmlns:p="http://schemas.openxmlformats.org/presentationml/2006/main">
-  <p:cSld name="Slide 6">
+  <p:cSld name="Slide 7">
     <p:bg>
       <p:bgPr>
         <a:solidFill>
@@ -4673,9 +5220,9 @@
 </p:sld>
 </file>
 
-<file path=ppt/slides/slide7.xml><?xml version="1.0" encoding="utf-8"?>
+<file path=ppt/slides/slide8.xml><?xml version="1.0" encoding="utf-8"?>
 <p:sld xmlns:a="http://schemas.openxmlformats.org/drawingml/2006/main" xmlns:r="http://schemas.openxmlformats.org/officeDocument/2006/relationships" xmlns:p="http://schemas.openxmlformats.org/presentationml/2006/main">
-  <p:cSld name="Slide 7">
+  <p:cSld name="Slide 8">
     <p:bg>
       <p:bgPr>
         <a:solidFill>
@@ -4984,9 +5531,9 @@
 </p:sld>
 </file>
 
-<file path=ppt/slides/slide8.xml><?xml version="1.0" encoding="utf-8"?>
+<file path=ppt/slides/slide9.xml><?xml version="1.0" encoding="utf-8"?>
 <p:sld xmlns:a="http://schemas.openxmlformats.org/drawingml/2006/main" xmlns:r="http://schemas.openxmlformats.org/officeDocument/2006/relationships" xmlns:p="http://schemas.openxmlformats.org/presentationml/2006/main">
-  <p:cSld name="Slide 8">
+  <p:cSld name="Slide 9">
     <p:bg>
       <p:bgPr>
         <a:solidFill>

</xml_diff>

<commit_message>
Add legal-notarization caveat with forward-looking Solana framing
</commit_message>
<xml_diff>
--- a/VaultMemo/VaultMemo_Pitch_Deck.pptx
+++ b/VaultMemo/VaultMemo_Pitch_Deck.pptx
@@ -2613,24 +2613,24 @@
         </p:nvSpPr>
         <p:spPr>
           <a:xfrm>
-            <a:off x="548640" y="5715000"/>
-            <a:ext cx="11064240" cy="548640"/>
-          </a:xfrm>
-          <a:prstGeom prst="rect">
-            <a:avLst/>
-          </a:prstGeom>
-          <a:noFill/>
-          <a:ln/>
-        </p:spPr>
-        <p:txBody>
-          <a:bodyPr wrap="square" lIns="0" tIns="0" rIns="0" bIns="0" rtlCol="0" anchor="ctr"/>
+            <a:off x="548640" y="5669280"/>
+            <a:ext cx="11064240" cy="640080"/>
+          </a:xfrm>
+          <a:prstGeom prst="rect">
+            <a:avLst/>
+          </a:prstGeom>
+          <a:noFill/>
+          <a:ln/>
+        </p:spPr>
+        <p:txBody>
+          <a:bodyPr wrap="square" lIns="0" tIns="0" rIns="0" bIns="0" rtlCol="0" anchor="t"/>
           <a:lstStyle/>
           <a:p>
             <a:pPr algn="ctr" indent="0" marL="0">
               <a:buNone/>
             </a:pPr>
             <a:r>
-              <a:rPr lang="en-US" sz="1400" i="1" dirty="0">
+              <a:rPr lang="en-US" sz="1300" i="1" dirty="0">
                 <a:solidFill>
                   <a:srgbClr val="7EE8B8"/>
                 </a:solidFill>
@@ -2638,9 +2638,9 @@
                 <a:ea typeface="Cambria" pitchFamily="34" charset="-122"/>
                 <a:cs typeface="Cambria" pitchFamily="34" charset="-120"/>
               </a:rPr>
-              <a:t>For these users, a screenshot or a private note isn't proof of anything. An independently verifiable, on-chain timestamp is.</a:t>
-            </a:r>
-            <a:endParaRPr lang="en-US" sz="1400" dirty="0"/>
+              <a:t>Cryptographic proof of existence today, not formal legal notarization — but as blockchain, and Solana in particular, extends its influence offline, on-chain records are likely to gain real-world legal recognition.</a:t>
+            </a:r>
+            <a:endParaRPr lang="en-US" sz="1300" dirty="0"/>
           </a:p>
         </p:txBody>
       </p:sp>

</xml_diff>

<commit_message>
Add French Marseille court precedent and content+proof co-preservation point
</commit_message>
<xml_diff>
--- a/VaultMemo/VaultMemo_Pitch_Deck.pptx
+++ b/VaultMemo/VaultMemo_Pitch_Deck.pptx
@@ -2613,8 +2613,8 @@
         </p:nvSpPr>
         <p:spPr>
           <a:xfrm>
-            <a:off x="548640" y="5669280"/>
-            <a:ext cx="11064240" cy="640080"/>
+            <a:off x="548640" y="5532120"/>
+            <a:ext cx="11064240" cy="868680"/>
           </a:xfrm>
           <a:prstGeom prst="rect">
             <a:avLst/>
@@ -2627,10 +2627,13 @@
           <a:lstStyle/>
           <a:p>
             <a:pPr algn="ctr" indent="0" marL="0">
-              <a:buNone/>
-            </a:pPr>
-            <a:r>
-              <a:rPr lang="en-US" sz="1300" i="1" dirty="0">
+              <a:lnSpc>
+                <a:spcPct val="120000"/>
+              </a:lnSpc>
+              <a:buNone/>
+            </a:pPr>
+            <a:r>
+              <a:rPr lang="en-US" sz="1200" i="1" dirty="0">
                 <a:solidFill>
                   <a:srgbClr val="7EE8B8"/>
                 </a:solidFill>
@@ -2638,9 +2641,9 @@
                 <a:ea typeface="Cambria" pitchFamily="34" charset="-122"/>
                 <a:cs typeface="Cambria" pitchFamily="34" charset="-120"/>
               </a:rPr>
-              <a:t>Cryptographic proof of existence today, not formal legal notarization — but as blockchain, and Solana in particular, extends its influence offline, on-chain records are likely to gain real-world legal recognition.</a:t>
-            </a:r>
-            <a:endParaRPr lang="en-US" sz="1300" dirty="0"/>
+              <a:t>Cryptographic proof of existence today, not formal legal notarization — but as blockchain, and Solana in particular, extends its influence offline, on-chain records are likely to gain real-world legal recognition. In 2025, France's Marseille Court already accepted a blockchain timestamp as copyright evidence.</a:t>
+            </a:r>
+            <a:endParaRPr lang="en-US" sz="1200" dirty="0"/>
           </a:p>
         </p:txBody>
       </p:sp>
@@ -3248,24 +3251,27 @@
         </p:nvSpPr>
         <p:spPr>
           <a:xfrm>
-            <a:off x="548640" y="5715000"/>
-            <a:ext cx="11064240" cy="548640"/>
-          </a:xfrm>
-          <a:prstGeom prst="rect">
-            <a:avLst/>
-          </a:prstGeom>
-          <a:noFill/>
-          <a:ln/>
-        </p:spPr>
-        <p:txBody>
-          <a:bodyPr wrap="square" lIns="0" tIns="0" rIns="0" bIns="0" rtlCol="0" anchor="ctr"/>
+            <a:off x="548640" y="5532120"/>
+            <a:ext cx="11064240" cy="868680"/>
+          </a:xfrm>
+          <a:prstGeom prst="rect">
+            <a:avLst/>
+          </a:prstGeom>
+          <a:noFill/>
+          <a:ln/>
+        </p:spPr>
+        <p:txBody>
+          <a:bodyPr wrap="square" lIns="0" tIns="0" rIns="0" bIns="0" rtlCol="0" anchor="t"/>
           <a:lstStyle/>
           <a:p>
             <a:pPr algn="ctr" indent="0" marL="0">
-              <a:buNone/>
-            </a:pPr>
-            <a:r>
-              <a:rPr lang="en-US" sz="1400" i="1" dirty="0">
+              <a:lnSpc>
+                <a:spcPct val="120000"/>
+              </a:lnSpc>
+              <a:buNone/>
+            </a:pPr>
+            <a:r>
+              <a:rPr lang="en-US" sz="1250" i="1" dirty="0">
                 <a:solidFill>
                   <a:srgbClr val="7EE8B8"/>
                 </a:solidFill>
@@ -3273,9 +3279,9 @@
                 <a:ea typeface="Cambria" pitchFamily="34" charset="-122"/>
                 <a:cs typeface="Cambria" pitchFamily="34" charset="-120"/>
               </a:rPr>
-              <a:t>No other vault app pairs true local-only encryption with an independently verifiable on-chain record.</a:t>
-            </a:r>
-            <a:endParaRPr lang="en-US" sz="1400" dirty="0"/>
+              <a:t>No other vault app pairs true local-only encryption with an independently verifiable on-chain record. And unlike typical blockchain notarization services that anchor only a hash while the original is managed separately, VaultMemo keeps the content and its proof together — recomputable and verifiable by anyone, without a third party.</a:t>
+            </a:r>
+            <a:endParaRPr lang="en-US" sz="1250" dirty="0"/>
           </a:p>
         </p:txBody>
       </p:sp>

</xml_diff>